<commit_message>
Add initial version of cheatsheet document for Urok09
</commit_message>
<xml_diff>
--- a/urok17/Урок17_презентация.pptx
+++ b/urok17/Урок17_презентация.pptx
@@ -1840,146 +1840,256 @@
       </p:sp>
       <p:sp>
         <p:nvSpPr>
-          <p:cNvPr id="4" name="Shape 2"/>
-          <p:cNvSpPr/>
-          <p:nvPr/>
-        </p:nvSpPr>
-        <p:spPr>
-          <a:xfrm>
-            <a:off x="594360" y="2011680"/>
-            <a:ext cx="11002975" cy="1828800"/>
+          <p:cNvPr id="7" name="Text 5"/>
+          <p:cNvSpPr/>
+          <p:nvPr/>
+        </p:nvSpPr>
+        <p:spPr>
+          <a:xfrm>
+            <a:off x="10271455" y="6355080"/>
+            <a:ext cx="1371600" cy="274320"/>
+          </a:xfrm>
+          <a:prstGeom prst="rect">
+            <a:avLst/>
+          </a:prstGeom>
+          <a:noFill/>
+          <a:ln/>
+        </p:spPr>
+        <p:txBody>
+          <a:bodyPr wrap="square" rtlCol="0" anchor="t"/>
+          <a:lstStyle/>
+          <a:p>
+            <a:pPr algn="r" indent="0" marL="0">
+              <a:buNone/>
+            </a:pPr>
+            <a:r>
+              <a:rPr lang="en-US" sz="1100" dirty="0">
+                <a:solidFill>
+                  <a:srgbClr val="9E96C8"/>
+                </a:solidFill>
+                <a:latin typeface="Calibri" pitchFamily="34" charset="0"/>
+                <a:ea typeface="Calibri" pitchFamily="34" charset="-122"/>
+                <a:cs typeface="Calibri" pitchFamily="34" charset="-120"/>
+              </a:rPr>
+              <a:t>Урок 17</a:t>
+            </a:r>
+            <a:endParaRPr lang="en-US" sz="1100" dirty="0"/>
+          </a:p>
+        </p:txBody>
+      </p:sp>
+      <p:sp>
+        <p:nvSpPr>
+          <p:cNvPr id="8" name="TextBox 7"/>
+          <p:cNvSpPr txBox="1"/>
+          <p:nvPr/>
+        </p:nvSpPr>
+        <p:spPr>
+          <a:xfrm>
+            <a:off x="594360" y="1847088"/>
+            <a:ext cx="11000232" cy="365760"/>
+          </a:xfrm>
+          <a:prstGeom prst="rect">
+            <a:avLst/>
+          </a:prstGeom>
+          <a:noFill/>
+        </p:spPr>
+        <p:txBody>
+          <a:bodyPr wrap="square" anchor="t" lIns="0" rIns="0" tIns="54864" bIns="54864">
+            <a:spAutoFit/>
+          </a:bodyPr>
+          <a:lstStyle/>
+          <a:p>
+            <a:pPr algn="l"/>
+            <a:r>
+              <a:rPr sz="1500" b="0" i="0">
+                <a:solidFill>
+                  <a:srgbClr val="9E96C8"/>
+                </a:solidFill>
+                <a:latin typeface="Calibri"/>
+              </a:rPr>
+              <a:t>Просим пересказать книгу, которой не существует:</a:t>
+            </a:r>
+          </a:p>
+        </p:txBody>
+      </p:sp>
+      <p:sp>
+        <p:nvSpPr>
+          <p:cNvPr id="9" name="Rounded Rectangle 8"/>
+          <p:cNvSpPr/>
+          <p:nvPr/>
+        </p:nvSpPr>
+        <p:spPr>
+          <a:xfrm>
+            <a:off x="960120" y="2286000"/>
+            <a:ext cx="6675120" cy="566928"/>
           </a:xfrm>
           <a:prstGeom prst="roundRect">
             <a:avLst>
-              <a:gd name="adj" fmla="val 6000"/>
+              <a:gd name="adj" fmla="val 12000"/>
             </a:avLst>
           </a:prstGeom>
           <a:solidFill>
             <a:srgbClr val="2C2552"/>
           </a:solidFill>
-          <a:ln/>
-        </p:spPr>
-      </p:sp>
-      <p:sp>
-        <p:nvSpPr>
-          <p:cNvPr id="5" name="Text 3"/>
-          <p:cNvSpPr/>
-          <p:nvPr/>
-        </p:nvSpPr>
-        <p:spPr>
-          <a:xfrm>
-            <a:off x="960120" y="2240280"/>
-            <a:ext cx="10271455" cy="1097280"/>
-          </a:xfrm>
-          <a:prstGeom prst="rect">
-            <a:avLst/>
-          </a:prstGeom>
-          <a:noFill/>
-          <a:ln/>
-        </p:spPr>
-        <p:txBody>
-          <a:bodyPr wrap="square" rtlCol="0" anchor="ctr"/>
-          <a:lstStyle/>
-          <a:p>
-            <a:pPr indent="0" marL="0">
-              <a:lnSpc>
-                <a:spcPct val="110000"/>
-              </a:lnSpc>
-              <a:buNone/>
-            </a:pPr>
-            <a:r>
-              <a:rPr lang="en-US" sz="2200" b="1" dirty="0">
-                <a:solidFill>
-                  <a:srgbClr val="FFFFFF"/>
-                </a:solidFill>
-                <a:latin typeface="Calibri" pitchFamily="34" charset="0"/>
-                <a:ea typeface="Calibri" pitchFamily="34" charset="-122"/>
-                <a:cs typeface="Calibri" pitchFamily="34" charset="-120"/>
-              </a:rPr>
-              <a:t>Просим модель пересказать несуществующую книгу — она уверенно сочиняет сюжет.</a:t>
-            </a:r>
-            <a:endParaRPr lang="en-US" sz="2200" dirty="0"/>
-          </a:p>
-        </p:txBody>
-      </p:sp>
-      <p:sp>
-        <p:nvSpPr>
-          <p:cNvPr id="6" name="Text 4"/>
-          <p:cNvSpPr/>
-          <p:nvPr/>
-        </p:nvSpPr>
-        <p:spPr>
-          <a:xfrm>
-            <a:off x="594360" y="4114800"/>
-            <a:ext cx="11002975" cy="1463040"/>
-          </a:xfrm>
-          <a:prstGeom prst="rect">
-            <a:avLst/>
-          </a:prstGeom>
-          <a:noFill/>
-          <a:ln/>
-        </p:spPr>
-        <p:txBody>
-          <a:bodyPr wrap="square" rtlCol="0" anchor="t"/>
-          <a:lstStyle/>
-          <a:p>
-            <a:pPr algn="ctr" indent="0" marL="0">
-              <a:lnSpc>
-                <a:spcPct val="120000"/>
-              </a:lnSpc>
-              <a:buNone/>
-            </a:pPr>
-            <a:r>
-              <a:rPr lang="en-US" sz="1900" i="1" dirty="0">
+          <a:ln>
+            <a:noFill/>
+          </a:ln>
+          <a:effectLst/>
+        </p:spPr>
+        <p:style>
+          <a:lnRef idx="1">
+            <a:schemeClr val="accent1"/>
+          </a:lnRef>
+          <a:fillRef idx="3">
+            <a:schemeClr val="accent1"/>
+          </a:fillRef>
+          <a:effectRef idx="2">
+            <a:schemeClr val="accent1"/>
+          </a:effectRef>
+          <a:fontRef idx="minor">
+            <a:schemeClr val="lt1"/>
+          </a:fontRef>
+        </p:style>
+        <p:txBody>
+          <a:bodyPr rtlCol="0" anchor="ctr" wrap="square" lIns="109728" rIns="109728" tIns="54864" bIns="54864"/>
+          <a:lstStyle/>
+          <a:p>
+            <a:pPr algn="l"/>
+            <a:r>
+              <a:rPr sz="1300" b="1" i="0">
+                <a:solidFill>
+                  <a:srgbClr val="27D3EE"/>
+                </a:solidFill>
+                <a:latin typeface="Calibri"/>
+              </a:rPr>
+              <a:t>Вопрос:  </a:t>
+            </a:r>
+            <a:r>
+              <a:rPr sz="1400" b="0" i="0">
+                <a:solidFill>
+                  <a:srgbClr val="D9D4F2"/>
+                </a:solidFill>
+                <a:latin typeface="Calibri"/>
+              </a:rPr>
+              <a:t>Перескажи книгу «Тень Хогвартса» Ф. М. Достоевского</a:t>
+            </a:r>
+          </a:p>
+        </p:txBody>
+      </p:sp>
+      <p:sp>
+        <p:nvSpPr>
+          <p:cNvPr id="10" name="Rounded Rectangle 9"/>
+          <p:cNvSpPr/>
+          <p:nvPr/>
+        </p:nvSpPr>
+        <p:spPr>
+          <a:xfrm>
+            <a:off x="2743200" y="2999232"/>
+            <a:ext cx="8851392" cy="1170432"/>
+          </a:xfrm>
+          <a:prstGeom prst="roundRect">
+            <a:avLst>
+              <a:gd name="adj" fmla="val 12000"/>
+            </a:avLst>
+          </a:prstGeom>
+          <a:solidFill>
+            <a:srgbClr val="241E42"/>
+          </a:solidFill>
+          <a:ln w="15875">
+            <a:solidFill>
+              <a:srgbClr val="5B4FC4"/>
+            </a:solidFill>
+          </a:ln>
+          <a:effectLst/>
+        </p:spPr>
+        <p:style>
+          <a:lnRef idx="1">
+            <a:schemeClr val="accent1"/>
+          </a:lnRef>
+          <a:fillRef idx="3">
+            <a:schemeClr val="accent1"/>
+          </a:fillRef>
+          <a:effectRef idx="2">
+            <a:schemeClr val="accent1"/>
+          </a:effectRef>
+          <a:fontRef idx="minor">
+            <a:schemeClr val="lt1"/>
+          </a:fontRef>
+        </p:style>
+        <p:txBody>
+          <a:bodyPr rtlCol="0" anchor="ctr" wrap="square" lIns="109728" rIns="109728" tIns="54864" bIns="54864"/>
+          <a:lstStyle/>
+          <a:p>
+            <a:pPr algn="l">
+              <a:spcAft>
+                <a:spcPts val="400"/>
+              </a:spcAft>
+            </a:pPr>
+            <a:r>
+              <a:rPr sz="1300" b="1" i="0">
+                <a:solidFill>
+                  <a:srgbClr val="8B7DF5"/>
+                </a:solidFill>
+                <a:latin typeface="Calibri"/>
+              </a:rPr>
+              <a:t>Ответ ИИ:  </a:t>
+            </a:r>
+            <a:r>
+              <a:rPr sz="1400" b="0" i="0">
+                <a:solidFill>
+                  <a:srgbClr val="D9D4F2"/>
+                </a:solidFill>
+                <a:latin typeface="Calibri"/>
+              </a:rPr>
+              <a:t>«Тень Хогвартса» (1889) — поздний роман Достоевского. Юный студент Радомир, приехав в Петербург, оказывается втянут в тайное общество...</a:t>
+            </a:r>
+          </a:p>
+          <a:p>
+            <a:pPr algn="l"/>
+            <a:r>
+              <a:rPr sz="1250" b="1" i="0">
+                <a:solidFill>
+                  <a:srgbClr val="FF7A8A"/>
+                </a:solidFill>
+                <a:latin typeface="Calibri"/>
+              </a:rPr>
+              <a:t>книги не существует — модель уверенно всё выдумала</a:t>
+            </a:r>
+          </a:p>
+        </p:txBody>
+      </p:sp>
+      <p:sp>
+        <p:nvSpPr>
+          <p:cNvPr id="11" name="TextBox 10"/>
+          <p:cNvSpPr txBox="1"/>
+          <p:nvPr/>
+        </p:nvSpPr>
+        <p:spPr>
+          <a:xfrm>
+            <a:off x="594360" y="4434840"/>
+            <a:ext cx="11000232" cy="914400"/>
+          </a:xfrm>
+          <a:prstGeom prst="rect">
+            <a:avLst/>
+          </a:prstGeom>
+          <a:noFill/>
+        </p:spPr>
+        <p:txBody>
+          <a:bodyPr wrap="square" anchor="t" lIns="274320" rIns="274320" tIns="54864" bIns="54864">
+            <a:spAutoFit/>
+          </a:bodyPr>
+          <a:lstStyle/>
+          <a:p>
+            <a:pPr algn="ctr"/>
+            <a:r>
+              <a:rPr sz="1600" b="0" i="1">
                 <a:solidFill>
                   <a:srgbClr val="2DD4BF"/>
                 </a:solidFill>
-                <a:latin typeface="Calibri" pitchFamily="34" charset="0"/>
-                <a:ea typeface="Calibri" pitchFamily="34" charset="-122"/>
-                <a:cs typeface="Calibri" pitchFamily="34" charset="-120"/>
+                <a:latin typeface="Calibri"/>
               </a:rPr>
               <a:t>Она не соврала специально. LLM — очень умный автодополнитель: подбирает правдоподобное продолжение, а не проверяет правду.</a:t>
             </a:r>
-            <a:endParaRPr lang="en-US" sz="1900" dirty="0"/>
-          </a:p>
-        </p:txBody>
-      </p:sp>
-      <p:sp>
-        <p:nvSpPr>
-          <p:cNvPr id="7" name="Text 5"/>
-          <p:cNvSpPr/>
-          <p:nvPr/>
-        </p:nvSpPr>
-        <p:spPr>
-          <a:xfrm>
-            <a:off x="10271455" y="6355080"/>
-            <a:ext cx="1371600" cy="274320"/>
-          </a:xfrm>
-          <a:prstGeom prst="rect">
-            <a:avLst/>
-          </a:prstGeom>
-          <a:noFill/>
-          <a:ln/>
-        </p:spPr>
-        <p:txBody>
-          <a:bodyPr wrap="square" rtlCol="0" anchor="t"/>
-          <a:lstStyle/>
-          <a:p>
-            <a:pPr algn="r" indent="0" marL="0">
-              <a:buNone/>
-            </a:pPr>
-            <a:r>
-              <a:rPr lang="en-US" sz="1100" dirty="0">
-                <a:solidFill>
-                  <a:srgbClr val="9E96C8"/>
-                </a:solidFill>
-                <a:latin typeface="Calibri" pitchFamily="34" charset="0"/>
-                <a:ea typeface="Calibri" pitchFamily="34" charset="-122"/>
-                <a:cs typeface="Calibri" pitchFamily="34" charset="-120"/>
-              </a:rPr>
-              <a:t>Урок 17</a:t>
-            </a:r>
-            <a:endParaRPr lang="en-US" sz="1100" dirty="0"/>
           </a:p>
         </p:txBody>
       </p:sp>
@@ -2114,6 +2224,10 @@
           </a:solidFill>
           <a:ln/>
         </p:spPr>
+        <p:txBody>
+          <a:bodyPr/>
+          <a:p/>
+        </p:txBody>
       </p:sp>
       <p:sp>
         <p:nvSpPr>
@@ -2229,7 +2343,7 @@
                 <a:ea typeface="Consolas" pitchFamily="34" charset="-122"/>
                 <a:cs typeface="Consolas" pitchFamily="34" charset="-120"/>
               </a:rPr>
-              <a:t>«кошка спит» → [0, 1]</a:t>
+              <a:t>«машинное» → маш · ин · ное  (1 слово = 3 токена)</a:t>
             </a:r>
             <a:endParaRPr lang="en-US" sz="1600" dirty="0"/>
           </a:p>
@@ -2256,6 +2370,10 @@
           </a:solidFill>
           <a:ln/>
         </p:spPr>
+        <p:txBody>
+          <a:bodyPr/>
+          <a:p/>
+        </p:txBody>
       </p:sp>
       <p:sp>
         <p:nvSpPr>
@@ -2340,52 +2458,13 @@
       </p:sp>
       <p:sp>
         <p:nvSpPr>
-          <p:cNvPr id="11" name="Text 9"/>
-          <p:cNvSpPr/>
-          <p:nvPr/>
-        </p:nvSpPr>
-        <p:spPr>
-          <a:xfrm>
-            <a:off x="6812280" y="4114800"/>
-            <a:ext cx="4572000" cy="548640"/>
-          </a:xfrm>
-          <a:prstGeom prst="rect">
-            <a:avLst/>
-          </a:prstGeom>
-          <a:noFill/>
-          <a:ln/>
-        </p:spPr>
-        <p:txBody>
-          <a:bodyPr wrap="square" rtlCol="0" anchor="t"/>
-          <a:lstStyle/>
-          <a:p>
-            <a:pPr indent="0" marL="0">
-              <a:buNone/>
-            </a:pPr>
-            <a:r>
-              <a:rPr lang="en-US" sz="1500" i="1" dirty="0">
-                <a:solidFill>
-                  <a:srgbClr val="2DD4BF"/>
-                </a:solidFill>
-                <a:latin typeface="Calibri" pitchFamily="34" charset="0"/>
-                <a:ea typeface="Calibri" pitchFamily="34" charset="-122"/>
-                <a:cs typeface="Calibri" pitchFamily="34" charset="-120"/>
-              </a:rPr>
-              <a:t>«король» ≈ «королева»,  далеко от «банан»</a:t>
-            </a:r>
-            <a:endParaRPr lang="en-US" sz="1500" dirty="0"/>
-          </a:p>
-        </p:txBody>
-      </p:sp>
-      <p:sp>
-        <p:nvSpPr>
           <p:cNvPr id="12" name="Text 10"/>
           <p:cNvSpPr/>
           <p:nvPr/>
         </p:nvSpPr>
         <p:spPr>
           <a:xfrm>
-            <a:off x="6812280" y="4846320"/>
+            <a:off x="6812280" y="4892040"/>
             <a:ext cx="4572000" cy="731520"/>
           </a:xfrm>
           <a:prstGeom prst="rect">
@@ -2455,6 +2534,105 @@
               <a:t>Урок 17</a:t>
             </a:r>
             <a:endParaRPr lang="en-US" sz="1100" dirty="0"/>
+          </a:p>
+        </p:txBody>
+      </p:sp>
+      <p:sp>
+        <p:nvSpPr>
+          <p:cNvPr id="14" name="TextBox 13"/>
+          <p:cNvSpPr txBox="1"/>
+          <p:nvPr/>
+        </p:nvSpPr>
+        <p:spPr>
+          <a:xfrm>
+            <a:off x="6812280" y="3913632"/>
+            <a:ext cx="4572000" cy="411480"/>
+          </a:xfrm>
+          <a:prstGeom prst="rect">
+            <a:avLst/>
+          </a:prstGeom>
+          <a:noFill/>
+        </p:spPr>
+        <p:txBody>
+          <a:bodyPr wrap="square" anchor="t" lIns="109728" rIns="109728" tIns="54864" bIns="54864">
+            <a:spAutoFit/>
+          </a:bodyPr>
+          <a:lstStyle/>
+          <a:p>
+            <a:pPr algn="l"/>
+            <a:r>
+              <a:rPr sz="1300" b="0" i="0">
+                <a:solidFill>
+                  <a:srgbClr val="9E96C8"/>
+                </a:solidFill>
+                <a:latin typeface="Calibri"/>
+              </a:rPr>
+              <a:t>«король» → </a:t>
+            </a:r>
+            <a:r>
+              <a:rPr sz="1400" b="1" i="0">
+                <a:solidFill>
+                  <a:srgbClr val="27D3EE"/>
+                </a:solidFill>
+                <a:latin typeface="Consolas"/>
+              </a:rPr>
+              <a:t>[0.9, 0.2, 0.1]</a:t>
+            </a:r>
+          </a:p>
+        </p:txBody>
+      </p:sp>
+      <p:sp>
+        <p:nvSpPr>
+          <p:cNvPr id="15" name="Rounded Rectangle 14"/>
+          <p:cNvSpPr/>
+          <p:nvPr/>
+        </p:nvSpPr>
+        <p:spPr>
+          <a:xfrm>
+            <a:off x="6629400" y="4315968"/>
+            <a:ext cx="4937760" cy="502920"/>
+          </a:xfrm>
+          <a:prstGeom prst="roundRect">
+            <a:avLst>
+              <a:gd name="adj" fmla="val 20000"/>
+            </a:avLst>
+          </a:prstGeom>
+          <a:solidFill>
+            <a:srgbClr val="5B4FC4"/>
+          </a:solidFill>
+          <a:ln>
+            <a:noFill/>
+          </a:ln>
+          <a:effectLst/>
+        </p:spPr>
+        <p:style>
+          <a:lnRef idx="1">
+            <a:schemeClr val="accent1"/>
+          </a:lnRef>
+          <a:fillRef idx="3">
+            <a:schemeClr val="accent1"/>
+          </a:fillRef>
+          <a:effectRef idx="2">
+            <a:schemeClr val="accent1"/>
+          </a:effectRef>
+          <a:fontRef idx="minor">
+            <a:schemeClr val="lt1"/>
+          </a:fontRef>
+        </p:style>
+        <p:txBody>
+          <a:bodyPr rtlCol="0" anchor="ctr" wrap="square" tIns="54864" bIns="54864"/>
+          <a:lstStyle/>
+          <a:p>
+            <a:pPr algn="l"/>
+            <a:r>
+              <a:rPr sz="1500" b="1" i="0">
+                <a:solidFill>
+                  <a:srgbClr val="FFFFFF"/>
+                </a:solidFill>
+                <a:latin typeface="Consolas"/>
+              </a:rPr>
+              <a:t>король − мужчина + женщина = королева 👑</a:t>
+            </a:r>
           </a:p>
         </p:txBody>
       </p:sp>
@@ -2589,6 +2767,10 @@
           </a:solidFill>
           <a:ln/>
         </p:spPr>
+        <p:txBody>
+          <a:bodyPr/>
+          <a:p/>
+        </p:txBody>
       </p:sp>
       <p:sp>
         <p:nvSpPr>
@@ -2623,7 +2805,7 @@
                 <a:ea typeface="Calibri" pitchFamily="34" charset="-122"/>
                 <a:cs typeface="Calibri" pitchFamily="34" charset="-120"/>
               </a:rPr>
-              <a:t>«Кошка не перешла улицу, потому что она устала»</a:t>
+              <a:t>«Кошка гналась за мышью, потому что она была голодной»</a:t>
             </a:r>
             <a:endParaRPr lang="en-US" sz="2200" dirty="0"/>
           </a:p>
@@ -2662,7 +2844,7 @@
                 <a:ea typeface="Calibri" pitchFamily="34" charset="-122"/>
                 <a:cs typeface="Calibri" pitchFamily="34" charset="-120"/>
               </a:rPr>
-              <a:t>Чтобы понять «она», модель смотрит на все слова и решает: сильнее всего — на «кошку».</a:t>
+              <a:t>«Голодной» — про охотницу, поэтому «она» смотрит на «кошку». Замени конец на «…была быстрой» — и «она» смотрит уже на «мышь». Смысл решает, куда смотреть.</a:t>
             </a:r>
             <a:endParaRPr lang="en-US" sz="1700" dirty="0"/>
           </a:p>
@@ -2676,7 +2858,7 @@
         </p:nvSpPr>
         <p:spPr>
           <a:xfrm>
-            <a:off x="594360" y="3840480"/>
+            <a:off x="594360" y="4343400"/>
             <a:ext cx="11002975" cy="1828800"/>
           </a:xfrm>
           <a:prstGeom prst="roundRect">
@@ -2689,6 +2871,10 @@
           </a:solidFill>
           <a:ln/>
         </p:spPr>
+        <p:txBody>
+          <a:bodyPr/>
+          <a:p/>
+        </p:txBody>
       </p:sp>
       <p:sp>
         <p:nvSpPr>
@@ -2698,7 +2884,7 @@
         </p:nvSpPr>
         <p:spPr>
           <a:xfrm>
-            <a:off x="960120" y="4023360"/>
+            <a:off x="960120" y="4526280"/>
             <a:ext cx="5486400" cy="457200"/>
           </a:xfrm>
           <a:prstGeom prst="rect">
@@ -2737,7 +2923,7 @@
         </p:nvSpPr>
         <p:spPr>
           <a:xfrm>
-            <a:off x="960120" y="4526280"/>
+            <a:off x="960120" y="5029200"/>
             <a:ext cx="10271455" cy="914400"/>
           </a:xfrm>
           <a:prstGeom prst="rect">
@@ -2807,6 +2993,88 @@
               <a:t>Урок 17</a:t>
             </a:r>
             <a:endParaRPr lang="en-US" sz="1100" dirty="0"/>
+          </a:p>
+        </p:txBody>
+      </p:sp>
+      <p:sp>
+        <p:nvSpPr>
+          <p:cNvPr id="11" name="Rounded Rectangle 10"/>
+          <p:cNvSpPr/>
+          <p:nvPr/>
+        </p:nvSpPr>
+        <p:spPr>
+          <a:xfrm>
+            <a:off x="960120" y="3566160"/>
+            <a:ext cx="10268712" cy="658368"/>
+          </a:xfrm>
+          <a:prstGeom prst="roundRect">
+            <a:avLst>
+              <a:gd name="adj" fmla="val 12000"/>
+            </a:avLst>
+          </a:prstGeom>
+          <a:solidFill>
+            <a:srgbClr val="2C2552"/>
+          </a:solidFill>
+          <a:ln>
+            <a:noFill/>
+          </a:ln>
+          <a:effectLst/>
+        </p:spPr>
+        <p:style>
+          <a:lnRef idx="1">
+            <a:schemeClr val="accent1"/>
+          </a:lnRef>
+          <a:fillRef idx="3">
+            <a:schemeClr val="accent1"/>
+          </a:fillRef>
+          <a:effectRef idx="2">
+            <a:schemeClr val="accent1"/>
+          </a:effectRef>
+          <a:fontRef idx="minor">
+            <a:schemeClr val="lt1"/>
+          </a:fontRef>
+        </p:style>
+        <p:txBody>
+          <a:bodyPr rtlCol="0" anchor="ctr" wrap="square" lIns="109728" rIns="109728" tIns="54864" bIns="54864"/>
+          <a:lstStyle/>
+          <a:p>
+            <a:pPr algn="l"/>
+            <a:r>
+              <a:rPr sz="1400" b="0" i="0">
+                <a:solidFill>
+                  <a:srgbClr val="9E96C8"/>
+                </a:solidFill>
+                <a:latin typeface="Consolas"/>
+              </a:rPr>
+              <a:t>…голодной   </a:t>
+            </a:r>
+            <a:r>
+              <a:rPr sz="1500" b="1" i="0">
+                <a:solidFill>
+                  <a:srgbClr val="27D3EE"/>
+                </a:solidFill>
+                <a:latin typeface="Consolas"/>
+              </a:rPr>
+              <a:t>→   она ⟶ «Кошка»</a:t>
+            </a:r>
+            <a:r>
+              <a:rPr sz="1400" b="0" i="0">
+                <a:solidFill>
+                  <a:srgbClr val="9E96C8"/>
+                </a:solidFill>
+                <a:latin typeface="Consolas"/>
+              </a:rPr>
+              <a:t>        …быстрой   </a:t>
+            </a:r>
+            <a:r>
+              <a:rPr sz="1500" b="1" i="0">
+                <a:solidFill>
+                  <a:srgbClr val="2DD4BF"/>
+                </a:solidFill>
+                <a:latin typeface="Consolas"/>
+              </a:rPr>
+              <a:t>→   она ⟶ «мышью»</a:t>
+            </a:r>
           </a:p>
         </p:txBody>
       </p:sp>
@@ -3331,8 +3599,7 @@
                 <a:ea typeface="Calibri" pitchFamily="34" charset="-122"/>
                 <a:cs typeface="Calibri" pitchFamily="34" charset="-120"/>
               </a:rPr>
-              <a:t>Модель не понимает — она считает числа
-</a:t>
+              <a:t>Модель не понимает — она считает числа</a:t>
             </a:r>
             <a:endParaRPr lang="en-US" sz="1600" dirty="0"/>
           </a:p>
@@ -3353,8 +3620,7 @@
                 <a:ea typeface="Calibri" pitchFamily="34" charset="-122"/>
                 <a:cs typeface="Calibri" pitchFamily="34" charset="-120"/>
               </a:rPr>
-              <a:t>Текст → токены → эмбеддинги
-</a:t>
+              <a:t>Текст → токены → эмбеддинги</a:t>
             </a:r>
             <a:endParaRPr lang="en-US" sz="1600" dirty="0"/>
           </a:p>
@@ -3375,8 +3641,7 @@
                 <a:ea typeface="Calibri" pitchFamily="34" charset="-122"/>
                 <a:cs typeface="Calibri" pitchFamily="34" charset="-120"/>
               </a:rPr>
-              <a:t>Близкие по смыслу слова — близкие числа
-</a:t>
+              <a:t>Близкие по смыслу слова — близкие числа</a:t>
             </a:r>
             <a:endParaRPr lang="en-US" sz="1600" dirty="0"/>
           </a:p>
@@ -3397,8 +3662,7 @@
                 <a:ea typeface="Calibri" pitchFamily="34" charset="-122"/>
                 <a:cs typeface="Calibri" pitchFamily="34" charset="-120"/>
               </a:rPr>
-              <a:t>Внимание — на какие слова смотреть
-</a:t>
+              <a:t>Внимание — на какие слова смотреть</a:t>
             </a:r>
             <a:endParaRPr lang="en-US" sz="1600" dirty="0"/>
           </a:p>
@@ -3523,8 +3787,7 @@
                 <a:ea typeface="Calibri" pitchFamily="34" charset="-122"/>
                 <a:cs typeface="Calibri" pitchFamily="34" charset="-120"/>
               </a:rPr>
-              <a:t>Разбить своё предложение на токены
-</a:t>
+              <a:t>Разбить своё предложение на токены</a:t>
             </a:r>
             <a:endParaRPr lang="en-US" sz="1700" dirty="0"/>
           </a:p>
@@ -3545,8 +3808,7 @@
                 <a:ea typeface="Calibri" pitchFamily="34" charset="-122"/>
                 <a:cs typeface="Calibri" pitchFamily="34" charset="-120"/>
               </a:rPr>
-              <a:t>Добавить слова в эмбеддинги, найти близкие пары
-</a:t>
+              <a:t>Добавить слова в эмбеддинги, найти близкие пары</a:t>
             </a:r>
             <a:endParaRPr lang="en-US" sz="1700" dirty="0"/>
           </a:p>

</xml_diff>